<commit_message>
System Design vi: sd-10-024 bay vi du chay duoc, sd-10-025 nen anh bang ma Python thuan; deck va PPTX
Co-Authored-By: Claude Sonnet 5.5 <noreply@anthropic.com>
Claude-Session: https://claude.ai/code/session_01JJCRKgpbfdpiPMwgBVozBY
</commit_message>
<xml_diff>
--- a/system-design-101/vi/lessons/sd-10-025/slides/sd-10-025.pptx
+++ b/system-design-101/vi/lessons/sd-10-025/slides/sd-10-025.pptx
@@ -15187,7 +15187,51 @@
                 <a:ea typeface="Be Vietnam Pro" pitchFamily="34" charset="-122"/>
                 <a:cs typeface="Be Vietnam Pro" pitchFamily="34" charset="-120"/>
               </a:rPr>
-              <a:t> ảnh,</a:t>
+              <a:t> ảnh</a:t>
+            </a:r>
+            <a:r>
+              <a:rPr lang="en-US" sz="2550" dirty="0" spc="-2" kern="0">
+                <a:solidFill>
+                  <a:srgbClr val="14161C"/>
+                </a:solidFill>
+                <a:latin typeface="Be Vietnam Pro" pitchFamily="34" charset="0"/>
+                <a:ea typeface="Be Vietnam Pro" pitchFamily="34" charset="-122"/>
+                <a:cs typeface="Be Vietnam Pro" pitchFamily="34" charset="-120"/>
+              </a:rPr>
+              <a:t> bằng</a:t>
+            </a:r>
+            <a:r>
+              <a:rPr lang="en-US" sz="2550" dirty="0" spc="2" kern="0">
+                <a:solidFill>
+                  <a:srgbClr val="14161C"/>
+                </a:solidFill>
+                <a:latin typeface="Be Vietnam Pro" pitchFamily="34" charset="0"/>
+                <a:ea typeface="Be Vietnam Pro" pitchFamily="34" charset="-122"/>
+                <a:cs typeface="Be Vietnam Pro" pitchFamily="34" charset="-120"/>
+              </a:rPr>
+              <a:t> mã</a:t>
+            </a:r>
+            <a:r>
+              <a:rPr lang="en-US" sz="2550" dirty="0" spc="8" kern="0">
+                <a:solidFill>
+                  <a:srgbClr val="14161C"/>
+                </a:solidFill>
+                <a:latin typeface="Be Vietnam Pro" pitchFamily="34" charset="0"/>
+                <a:ea typeface="Be Vietnam Pro" pitchFamily="34" charset="-122"/>
+                <a:cs typeface="Be Vietnam Pro" pitchFamily="34" charset="-120"/>
+              </a:rPr>
+              <a:t> Python</a:t>
+            </a:r>
+            <a:r>
+              <a:rPr lang="en-US" sz="2550" dirty="0" spc="1" kern="0">
+                <a:solidFill>
+                  <a:srgbClr val="14161C"/>
+                </a:solidFill>
+                <a:latin typeface="Be Vietnam Pro" pitchFamily="34" charset="0"/>
+                <a:ea typeface="Be Vietnam Pro" pitchFamily="34" charset="-122"/>
+                <a:cs typeface="Be Vietnam Pro" pitchFamily="34" charset="-120"/>
+              </a:rPr>
+              <a:t> thuần,</a:t>
             </a:r>
             <a:r>
               <a:rPr lang="en-US" sz="2550" dirty="0" spc="7" kern="0">
@@ -15212,7 +15256,7 @@
               <a:t> hết một</a:t>
             </a:r>
             <a:r>
-              <a:rPr lang="en-US" sz="2550" dirty="0" spc="1" kern="0">
+              <a:rPr lang="en-US" sz="2550" dirty="0" spc="0" kern="0">
                 <a:solidFill>
                   <a:srgbClr val="14161C"/>
                 </a:solidFill>

</xml_diff>